<commit_message>
Added sections to presentation
</commit_message>
<xml_diff>
--- a/Presentation/Blood_bank_Reporting_System.pptx
+++ b/Presentation/Blood_bank_Reporting_System.pptx
@@ -151,12 +151,13 @@
           <p14:sldIdLst>
             <p14:sldId id="2606"/>
             <p14:sldId id="2607"/>
+          </p14:sldIdLst>
+        </p14:section>
+        <p14:section name="Conclusion" id="{9F517D69-BA0F-4576-9029-A6E5D6D8E54F}">
+          <p14:sldIdLst>
             <p14:sldId id="2615"/>
             <p14:sldId id="2616"/>
           </p14:sldIdLst>
-        </p14:section>
-        <p14:section name="Conclusion and Business Value" id="{07F79266-9DAF-4350-A7FF-36158B3533ED}">
-          <p14:sldIdLst/>
         </p14:section>
       </p14:sectionLst>
     </p:ext>
@@ -167,7 +168,7 @@
 <file path=ppt/revisionInfo.xml><?xml version="1.0" encoding="utf-8"?>
 <p1510:revInfo xmlns:a="http://schemas.openxmlformats.org/drawingml/2006/main" xmlns:r="http://schemas.openxmlformats.org/officeDocument/2006/relationships" xmlns:p1510="http://schemas.microsoft.com/office/powerpoint/2015/10/main">
   <p1510:revLst>
-    <p1510:client id="{34F039B8-E446-4C3A-E3D5-DEB13932074E}" v="30" dt="2026-04-24T12:18:20.186"/>
+    <p1510:client id="{34F039B8-E446-4C3A-E3D5-DEB13932074E}" v="33" dt="2026-04-24T12:25:27.710"/>
     <p1510:client id="{465CA162-4018-C352-BC0F-D6C68AE60CBB}" v="196" dt="2026-04-24T10:49:04.759"/>
     <p1510:client id="{BC2A5A5B-9EEA-1748-8BB4-FC7EB697DDA8}" v="7" dt="2026-04-23T14:37:50.993"/>
   </p1510:revLst>

</xml_diff>